<commit_message>
Update students' slides for 11/14
</commit_message>
<xml_diff>
--- a/TEACHING/files/2019/1114/Fairness_Ankit.pptx
+++ b/TEACHING/files/2019/1114/Fairness_Ankit.pptx
@@ -41,23 +41,24 @@
     <p:sldId id="286" r:id="rId36"/>
     <p:sldId id="287" r:id="rId37"/>
     <p:sldId id="288" r:id="rId38"/>
+    <p:sldId id="289" r:id="rId39"/>
   </p:sldIdLst>
   <p:sldSz cy="5143500" cx="9144000"/>
   <p:notesSz cx="6858000" cy="9144000"/>
   <p:embeddedFontLst>
     <p:embeddedFont>
       <p:font typeface="Raleway"/>
-      <p:regular r:id="rId39"/>
-      <p:bold r:id="rId40"/>
-      <p:italic r:id="rId41"/>
-      <p:boldItalic r:id="rId42"/>
+      <p:regular r:id="rId40"/>
+      <p:bold r:id="rId41"/>
+      <p:italic r:id="rId42"/>
+      <p:boldItalic r:id="rId43"/>
     </p:embeddedFont>
     <p:embeddedFont>
       <p:font typeface="Lato"/>
-      <p:regular r:id="rId43"/>
-      <p:bold r:id="rId44"/>
-      <p:italic r:id="rId45"/>
-      <p:boldItalic r:id="rId46"/>
+      <p:regular r:id="rId44"/>
+      <p:bold r:id="rId45"/>
+      <p:italic r:id="rId46"/>
+      <p:boldItalic r:id="rId47"/>
     </p:embeddedFont>
   </p:embeddedFontLst>
   <p:defaultTextStyle>
@@ -3016,7 +3017,7 @@
   <p:cSld>
     <p:spTree>
       <p:nvGrpSpPr>
-        <p:cNvPr id="274" name="Shape 274"/>
+        <p:cNvPr id="275" name="Shape 275"/>
         <p:cNvGrpSpPr/>
         <p:nvPr/>
       </p:nvGrpSpPr>
@@ -3030,7 +3031,7 @@
       </p:grpSpPr>
       <p:sp>
         <p:nvSpPr>
-          <p:cNvPr id="275" name="Google Shape;275;g74442d41a2_1_42:notes"/>
+          <p:cNvPr id="276" name="Google Shape;276;g74442d41a2_1_42:notes"/>
           <p:cNvSpPr/>
           <p:nvPr>
             <p:ph idx="2" type="sldImg"/>
@@ -3065,7 +3066,7 @@
       </p:sp>
       <p:sp>
         <p:nvSpPr>
-          <p:cNvPr id="276" name="Google Shape;276;g74442d41a2_1_42:notes"/>
+          <p:cNvPr id="277" name="Google Shape;277;g74442d41a2_1_42:notes"/>
           <p:cNvSpPr txBox="1"/>
           <p:nvPr>
             <p:ph idx="1" type="body"/>
@@ -3115,7 +3116,7 @@
   <p:cSld>
     <p:spTree>
       <p:nvGrpSpPr>
-        <p:cNvPr id="280" name="Shape 280"/>
+        <p:cNvPr id="281" name="Shape 281"/>
         <p:cNvGrpSpPr/>
         <p:nvPr/>
       </p:nvGrpSpPr>
@@ -3129,7 +3130,7 @@
       </p:grpSpPr>
       <p:sp>
         <p:nvSpPr>
-          <p:cNvPr id="281" name="Google Shape;281;g74442d41a2_1_48:notes"/>
+          <p:cNvPr id="282" name="Google Shape;282;g74442d41a2_1_48:notes"/>
           <p:cNvSpPr/>
           <p:nvPr>
             <p:ph idx="2" type="sldImg"/>
@@ -3164,7 +3165,7 @@
       </p:sp>
       <p:sp>
         <p:nvSpPr>
-          <p:cNvPr id="282" name="Google Shape;282;g74442d41a2_1_48:notes"/>
+          <p:cNvPr id="283" name="Google Shape;283;g74442d41a2_1_48:notes"/>
           <p:cNvSpPr txBox="1"/>
           <p:nvPr>
             <p:ph idx="1" type="body"/>
@@ -3214,7 +3215,7 @@
   <p:cSld>
     <p:spTree>
       <p:nvGrpSpPr>
-        <p:cNvPr id="286" name="Shape 286"/>
+        <p:cNvPr id="289" name="Shape 289"/>
         <p:cNvGrpSpPr/>
         <p:nvPr/>
       </p:nvGrpSpPr>
@@ -3228,7 +3229,7 @@
       </p:grpSpPr>
       <p:sp>
         <p:nvSpPr>
-          <p:cNvPr id="287" name="Google Shape;287;g74442d41a2_1_54:notes"/>
+          <p:cNvPr id="290" name="Google Shape;290;g74442d41a2_1_54:notes"/>
           <p:cNvSpPr/>
           <p:nvPr>
             <p:ph idx="2" type="sldImg"/>
@@ -3263,7 +3264,7 @@
       </p:sp>
       <p:sp>
         <p:nvSpPr>
-          <p:cNvPr id="288" name="Google Shape;288;g74442d41a2_1_54:notes"/>
+          <p:cNvPr id="291" name="Google Shape;291;g74442d41a2_1_54:notes"/>
           <p:cNvSpPr txBox="1"/>
           <p:nvPr>
             <p:ph idx="1" type="body"/>
@@ -3313,7 +3314,7 @@
   <p:cSld>
     <p:spTree>
       <p:nvGrpSpPr>
-        <p:cNvPr id="292" name="Shape 292"/>
+        <p:cNvPr id="295" name="Shape 295"/>
         <p:cNvGrpSpPr/>
         <p:nvPr/>
       </p:nvGrpSpPr>
@@ -3327,7 +3328,7 @@
       </p:grpSpPr>
       <p:sp>
         <p:nvSpPr>
-          <p:cNvPr id="293" name="Google Shape;293;g74442d41a2_1_60:notes"/>
+          <p:cNvPr id="296" name="Google Shape;296;g74442d41a2_1_60:notes"/>
           <p:cNvSpPr/>
           <p:nvPr>
             <p:ph idx="2" type="sldImg"/>
@@ -3362,7 +3363,106 @@
       </p:sp>
       <p:sp>
         <p:nvSpPr>
-          <p:cNvPr id="294" name="Google Shape;294;g74442d41a2_1_60:notes"/>
+          <p:cNvPr id="297" name="Google Shape;297;g74442d41a2_1_60:notes"/>
+          <p:cNvSpPr txBox="1"/>
+          <p:nvPr>
+            <p:ph idx="1" type="body"/>
+          </p:nvPr>
+        </p:nvSpPr>
+        <p:spPr>
+          <a:xfrm>
+            <a:off x="685800" y="4343400"/>
+            <a:ext cx="5486400" cy="4114800"/>
+          </a:xfrm>
+          <a:prstGeom prst="rect">
+            <a:avLst/>
+          </a:prstGeom>
+        </p:spPr>
+        <p:txBody>
+          <a:bodyPr anchorCtr="0" anchor="t" bIns="91425" lIns="91425" spcFirstLastPara="1" rIns="91425" wrap="square" tIns="91425">
+            <a:noAutofit/>
+          </a:bodyPr>
+          <a:lstStyle/>
+          <a:p>
+            <a:pPr indent="0" lvl="0" marL="0" rtl="0" algn="l">
+              <a:spcBef>
+                <a:spcPts val="0"/>
+              </a:spcBef>
+              <a:spcAft>
+                <a:spcPts val="0"/>
+              </a:spcAft>
+              <a:buNone/>
+            </a:pPr>
+            <a:r>
+              <a:t/>
+            </a:r>
+            <a:endParaRPr/>
+          </a:p>
+        </p:txBody>
+      </p:sp>
+    </p:spTree>
+  </p:cSld>
+  <p:clrMapOvr>
+    <a:masterClrMapping/>
+  </p:clrMapOvr>
+</p:notes>
+</file>
+
+<file path=ppt/notesSlides/notesSlide34.xml><?xml version="1.0" encoding="utf-8"?>
+<p:notes xmlns:a="http://schemas.openxmlformats.org/drawingml/2006/main" xmlns:r="http://schemas.openxmlformats.org/officeDocument/2006/relationships" xmlns:mc="http://schemas.openxmlformats.org/markup-compatibility/2006" xmlns:mv="urn:schemas-microsoft-com:mac:vml" xmlns:p="http://schemas.openxmlformats.org/presentationml/2006/main" xmlns:c="http://schemas.openxmlformats.org/drawingml/2006/chart" xmlns:dgm="http://schemas.openxmlformats.org/drawingml/2006/diagram" xmlns:o="urn:schemas-microsoft-com:office:office" xmlns:v="urn:schemas-microsoft-com:vml" xmlns:pvml="urn:schemas-microsoft-com:office:powerpoint" xmlns:com="http://schemas.openxmlformats.org/drawingml/2006/compatibility" xmlns:p14="http://schemas.microsoft.com/office/powerpoint/2010/main" xmlns:p15="http://schemas.microsoft.com/office/powerpoint/2012/main" showMasterPhAnim="0" showMasterSp="0">
+  <p:cSld>
+    <p:spTree>
+      <p:nvGrpSpPr>
+        <p:cNvPr id="301" name="Shape 301"/>
+        <p:cNvGrpSpPr/>
+        <p:nvPr/>
+      </p:nvGrpSpPr>
+      <p:grpSpPr>
+        <a:xfrm>
+          <a:off x="0" y="0"/>
+          <a:ext cx="0" cy="0"/>
+          <a:chOff x="0" y="0"/>
+          <a:chExt cx="0" cy="0"/>
+        </a:xfrm>
+      </p:grpSpPr>
+      <p:sp>
+        <p:nvSpPr>
+          <p:cNvPr id="302" name="Google Shape;302;g74442d41a2_1_72:notes"/>
+          <p:cNvSpPr/>
+          <p:nvPr>
+            <p:ph idx="2" type="sldImg"/>
+          </p:nvPr>
+        </p:nvSpPr>
+        <p:spPr>
+          <a:xfrm>
+            <a:off x="381309" y="685800"/>
+            <a:ext cx="6096000" cy="3429000"/>
+          </a:xfrm>
+          <a:custGeom>
+            <a:rect b="b" l="l" r="r" t="t"/>
+            <a:pathLst>
+              <a:path extrusionOk="0" h="120000" w="120000">
+                <a:moveTo>
+                  <a:pt x="0" y="0"/>
+                </a:moveTo>
+                <a:lnTo>
+                  <a:pt x="120000" y="0"/>
+                </a:lnTo>
+                <a:lnTo>
+                  <a:pt x="120000" y="120000"/>
+                </a:lnTo>
+                <a:lnTo>
+                  <a:pt x="0" y="120000"/>
+                </a:lnTo>
+                <a:close/>
+              </a:path>
+            </a:pathLst>
+          </a:custGeom>
+        </p:spPr>
+      </p:sp>
+      <p:sp>
+        <p:nvSpPr>
+          <p:cNvPr id="303" name="Google Shape;303;g74442d41a2_1_72:notes"/>
           <p:cNvSpPr txBox="1"/>
           <p:nvPr>
             <p:ph idx="1" type="body"/>
@@ -10679,8 +10779,8 @@
         </p:nvSpPr>
         <p:spPr>
           <a:xfrm>
-            <a:off x="729450" y="3212200"/>
-            <a:ext cx="4428300" cy="541200"/>
+            <a:off x="777425" y="3212200"/>
+            <a:ext cx="5004000" cy="541200"/>
           </a:xfrm>
           <a:prstGeom prst="rect">
             <a:avLst/>
@@ -10702,10 +10802,10 @@
               <a:buNone/>
             </a:pPr>
             <a:r>
-              <a:rPr lang="en" sz="1000"/>
+              <a:rPr lang="en" sz="1100"/>
               <a:t>On Formalizing Fairness in Prediction with Machine Learning - Gajane et al.</a:t>
             </a:r>
-            <a:endParaRPr sz="1000"/>
+            <a:endParaRPr sz="1100"/>
           </a:p>
           <a:p>
             <a:pPr indent="0" lvl="0" marL="0" rtl="0" algn="l">
@@ -10718,14 +10818,14 @@
               <a:buNone/>
             </a:pPr>
             <a:r>
-              <a:rPr lang="en" sz="1000"/>
+              <a:rPr lang="en" sz="1100"/>
               <a:t>Avoiding Discrimination through Causal Reasoning </a:t>
             </a:r>
             <a:r>
-              <a:rPr lang="en" sz="1000"/>
+              <a:rPr lang="en" sz="1100"/>
               <a:t>- Kilbertus et al.</a:t>
             </a:r>
-            <a:endParaRPr sz="1000"/>
+            <a:endParaRPr sz="1100"/>
           </a:p>
         </p:txBody>
       </p:sp>
@@ -10764,7 +10864,7 @@
               <a:buNone/>
             </a:pPr>
             <a:r>
-              <a:rPr lang="en">
+              <a:rPr lang="en" sz="1500">
                 <a:latin typeface="Lato"/>
                 <a:ea typeface="Lato"/>
                 <a:cs typeface="Lato"/>
@@ -10772,7 +10872,7 @@
               </a:rPr>
               <a:t>Presented by</a:t>
             </a:r>
-            <a:endParaRPr>
+            <a:endParaRPr sz="1500">
               <a:latin typeface="Lato"/>
               <a:ea typeface="Lato"/>
               <a:cs typeface="Lato"/>
@@ -10790,7 +10890,7 @@
               <a:buNone/>
             </a:pPr>
             <a:r>
-              <a:rPr lang="en">
+              <a:rPr lang="en" sz="1500">
                 <a:latin typeface="Lato"/>
                 <a:ea typeface="Lato"/>
                 <a:cs typeface="Lato"/>
@@ -10798,7 +10898,7 @@
               </a:rPr>
               <a:t>Ankit Raj</a:t>
             </a:r>
-            <a:endParaRPr>
+            <a:endParaRPr sz="1500">
               <a:latin typeface="Lato"/>
               <a:ea typeface="Lato"/>
               <a:cs typeface="Lato"/>
@@ -10911,6 +11011,9 @@
           </a:p>
           <a:p>
             <a:pPr indent="-311150" lvl="0" marL="457200" rtl="0" algn="l">
+              <a:lnSpc>
+                <a:spcPct val="120000"/>
+              </a:lnSpc>
               <a:spcBef>
                 <a:spcPts val="1600"/>
               </a:spcBef>
@@ -10928,6 +11031,9 @@
           </a:p>
           <a:p>
             <a:pPr indent="-311150" lvl="0" marL="457200" rtl="0" algn="l">
+              <a:lnSpc>
+                <a:spcPct val="120000"/>
+              </a:lnSpc>
               <a:spcBef>
                 <a:spcPts val="0"/>
               </a:spcBef>
@@ -10953,6 +11059,9 @@
           </a:p>
           <a:p>
             <a:pPr indent="-311150" lvl="0" marL="457200" rtl="0" algn="l">
+              <a:lnSpc>
+                <a:spcPct val="120000"/>
+              </a:lnSpc>
               <a:spcBef>
                 <a:spcPts val="0"/>
               </a:spcBef>
@@ -10970,6 +11079,9 @@
           </a:p>
           <a:p>
             <a:pPr indent="-311150" lvl="0" marL="457200" rtl="0" algn="l">
+              <a:lnSpc>
+                <a:spcPct val="120000"/>
+              </a:lnSpc>
               <a:spcBef>
                 <a:spcPts val="0"/>
               </a:spcBef>
@@ -10988,7 +11100,7 @@
           <a:p>
             <a:pPr indent="0" lvl="0" marL="0" rtl="0" algn="l">
               <a:spcBef>
-                <a:spcPts val="1600"/>
+                <a:spcPts val="0"/>
               </a:spcBef>
               <a:spcAft>
                 <a:spcPts val="1600"/>
@@ -13334,7 +13446,23 @@
                   <a:srgbClr val="000000"/>
                 </a:solidFill>
               </a:rPr>
-              <a:t>Unequal distribution of social benefits is only considered fair when it results from the intentional decisions and actions of the concerned individuals</a:t>
+              <a:t>Unequal distribution of social benefits is only considered fair when it results from the </a:t>
+            </a:r>
+            <a:r>
+              <a:rPr lang="en" sz="1400" u="sng">
+                <a:solidFill>
+                  <a:srgbClr val="000000"/>
+                </a:solidFill>
+              </a:rPr>
+              <a:t>intentional decisions and actions </a:t>
+            </a:r>
+            <a:r>
+              <a:rPr lang="en" sz="1400">
+                <a:solidFill>
+                  <a:srgbClr val="000000"/>
+                </a:solidFill>
+              </a:rPr>
+              <a:t>of the concerned individuals</a:t>
             </a:r>
             <a:endParaRPr sz="1400">
               <a:solidFill>
@@ -13358,7 +13486,15 @@
             </a:pPr>
             <a:r>
               <a:rPr lang="en" sz="1400"/>
-              <a:t>Each individual’s unchosen circumstances including the natural endowments which should be offset to achieve fairness</a:t>
+              <a:t>Each individual’s unchosen circumstances including the </a:t>
+            </a:r>
+            <a:r>
+              <a:rPr lang="en" sz="1400" u="sng"/>
+              <a:t>natural endowments which should be offset</a:t>
+            </a:r>
+            <a:r>
+              <a:rPr lang="en" sz="1400"/>
+              <a:t> to achieve fairness</a:t>
             </a:r>
             <a:endParaRPr sz="1400"/>
           </a:p>
@@ -13787,7 +13923,23 @@
                   <a:srgbClr val="000000"/>
                 </a:solidFill>
               </a:rPr>
-              <a:t>People should not be held responsible for attributes they had no say in to include personal attributes which cause difficulty in developing </a:t>
+              <a:t>People should not be held responsible for </a:t>
+            </a:r>
+            <a:r>
+              <a:rPr lang="en" sz="1400" u="sng">
+                <a:solidFill>
+                  <a:srgbClr val="000000"/>
+                </a:solidFill>
+              </a:rPr>
+              <a:t>attributes they had no say in</a:t>
+            </a:r>
+            <a:r>
+              <a:rPr lang="en" sz="1400">
+                <a:solidFill>
+                  <a:srgbClr val="000000"/>
+                </a:solidFill>
+              </a:rPr>
+              <a:t> to include personal attributes which cause difficulty in developing </a:t>
             </a:r>
             <a:r>
               <a:rPr i="1" lang="en" sz="1400">
@@ -13851,7 +14003,39 @@
                   <a:srgbClr val="000000"/>
                 </a:solidFill>
               </a:rPr>
-              <a:t>Variations related to the protected attributes like age, sex, gender, race, caste give individuals unequal powers to achieve goals even when they have the same opportunities.</a:t>
+              <a:t>Variations related to the protected attributes like age, sex, gender, race, caste give individuals </a:t>
+            </a:r>
+            <a:r>
+              <a:rPr lang="en" sz="1400" u="sng">
+                <a:solidFill>
+                  <a:srgbClr val="000000"/>
+                </a:solidFill>
+              </a:rPr>
+              <a:t>unequal powers</a:t>
+            </a:r>
+            <a:r>
+              <a:rPr lang="en" sz="1400">
+                <a:solidFill>
+                  <a:srgbClr val="000000"/>
+                </a:solidFill>
+              </a:rPr>
+              <a:t> to achieve goals even when they have the </a:t>
+            </a:r>
+            <a:r>
+              <a:rPr lang="en" sz="1400" u="sng">
+                <a:solidFill>
+                  <a:srgbClr val="000000"/>
+                </a:solidFill>
+              </a:rPr>
+              <a:t>same opportunities</a:t>
+            </a:r>
+            <a:r>
+              <a:rPr lang="en" sz="1400">
+                <a:solidFill>
+                  <a:srgbClr val="000000"/>
+                </a:solidFill>
+              </a:rPr>
+              <a:t>.</a:t>
             </a:r>
             <a:endParaRPr sz="1400">
               <a:solidFill>
@@ -13879,7 +14063,23 @@
                   <a:srgbClr val="000000"/>
                 </a:solidFill>
               </a:rPr>
-              <a:t> In order to equalize capabilities, people should be compensated for their unequal powers to convert opportunities into functionings.</a:t>
+              <a:t> In order to equalize capabilities, people should be </a:t>
+            </a:r>
+            <a:r>
+              <a:rPr lang="en" sz="1400" u="sng">
+                <a:solidFill>
+                  <a:srgbClr val="000000"/>
+                </a:solidFill>
+              </a:rPr>
+              <a:t>compensated for their unequal powers</a:t>
+            </a:r>
+            <a:r>
+              <a:rPr lang="en" sz="1400">
+                <a:solidFill>
+                  <a:srgbClr val="000000"/>
+                </a:solidFill>
+              </a:rPr>
+              <a:t> to convert opportunities into functionings.</a:t>
             </a:r>
             <a:endParaRPr sz="1400">
               <a:solidFill>
@@ -14130,9 +14330,13 @@
             </a:pPr>
             <a:r>
               <a:rPr lang="en"/>
-              <a:t>This paper frames the problem of discrimination based on protected attributes in the language of causal reasoning</a:t>
-            </a:r>
-            <a:endParaRPr/>
+              <a:t>This paper frames the problem of discrimination based on protected attributes in the language of </a:t>
+            </a:r>
+            <a:r>
+              <a:rPr lang="en" u="sng"/>
+              <a:t>causal reasoning</a:t>
+            </a:r>
+            <a:endParaRPr u="sng"/>
           </a:p>
           <a:p>
             <a:pPr indent="-311150" lvl="0" marL="457200" rtl="0" algn="l">
@@ -14150,7 +14354,15 @@
             </a:pPr>
             <a:r>
               <a:rPr lang="en"/>
-              <a:t>“What do we want to assume about our model of the causal data generating process?</a:t>
+              <a:t>“What do we want to assume about our model of the </a:t>
+            </a:r>
+            <a:r>
+              <a:rPr lang="en" u="sng"/>
+              <a:t>causal data generating process</a:t>
+            </a:r>
+            <a:r>
+              <a:rPr lang="en"/>
+              <a:t>?”</a:t>
             </a:r>
             <a:endParaRPr/>
           </a:p>
@@ -14732,13 +14944,22 @@
               <a:buChar char="●"/>
             </a:pPr>
             <a:r>
+              <a:rPr lang="en" u="sng">
+                <a:latin typeface="Lato"/>
+                <a:ea typeface="Lato"/>
+                <a:cs typeface="Lato"/>
+                <a:sym typeface="Lato"/>
+              </a:rPr>
+              <a:t>Structural equation model</a:t>
+            </a:r>
+            <a:r>
               <a:rPr lang="en">
                 <a:latin typeface="Lato"/>
                 <a:ea typeface="Lato"/>
                 <a:cs typeface="Lato"/>
                 <a:sym typeface="Lato"/>
               </a:rPr>
-              <a:t>Structural equation model represents the dependencies between connected nodes</a:t>
+              <a:t> represents the dependencies between connected nodes</a:t>
             </a:r>
             <a:endParaRPr>
               <a:latin typeface="Lato"/>
@@ -14816,7 +15037,7 @@
                 <a:cs typeface="Lato"/>
                 <a:sym typeface="Lato"/>
               </a:rPr>
-              <a:t>The equation model and the corresponding graph can be viewed as data generatiing model</a:t>
+              <a:t>The equation model and the corresponding graph can be viewed as data generating model</a:t>
             </a:r>
             <a:endParaRPr>
               <a:latin typeface="Lato"/>
@@ -15049,12 +15270,20 @@
               <a:t>What matters is the </a:t>
             </a:r>
             <a:r>
+              <a:rPr i="1" lang="en" sz="1400" u="sng">
+                <a:solidFill>
+                  <a:srgbClr val="000000"/>
+                </a:solidFill>
+              </a:rPr>
+              <a:t>direct effect</a:t>
+            </a:r>
+            <a:r>
               <a:rPr i="1" lang="en" sz="1400">
                 <a:solidFill>
                   <a:srgbClr val="000000"/>
                 </a:solidFill>
               </a:rPr>
-              <a:t>direct effect </a:t>
+              <a:t> </a:t>
             </a:r>
             <a:r>
               <a:rPr lang="en" sz="1400">
@@ -15065,12 +15294,20 @@
               <a:t>of the protected attribute (here, gender A) on the decision (here, college admission R) that cannot be ascribed to a </a:t>
             </a:r>
             <a:r>
+              <a:rPr i="1" lang="en" sz="1400" u="sng">
+                <a:solidFill>
+                  <a:srgbClr val="000000"/>
+                </a:solidFill>
+              </a:rPr>
+              <a:t>resolving variable</a:t>
+            </a:r>
+            <a:r>
               <a:rPr i="1" lang="en" sz="1400">
                 <a:solidFill>
                   <a:srgbClr val="000000"/>
                 </a:solidFill>
               </a:rPr>
-              <a:t>resolving variable </a:t>
+              <a:t> </a:t>
             </a:r>
             <a:r>
               <a:rPr lang="en" sz="1400">
@@ -15478,7 +15715,23 @@
             </a:pPr>
             <a:r>
               <a:rPr lang="en"/>
-              <a:t>Protected attributes, A have proxies, such as name, visual features, languages spoken etc. in the features</a:t>
+              <a:t>Protected attributes, </a:t>
+            </a:r>
+            <a:r>
+              <a:rPr b="1" i="1" lang="en"/>
+              <a:t>A</a:t>
+            </a:r>
+            <a:r>
+              <a:rPr lang="en"/>
+              <a:t> have proxies </a:t>
+            </a:r>
+            <a:r>
+              <a:rPr b="1" i="1" lang="en"/>
+              <a:t>P</a:t>
+            </a:r>
+            <a:r>
+              <a:rPr lang="en"/>
+              <a:t>, such as name, visual features, languages spoken etc. in the features</a:t>
             </a:r>
             <a:endParaRPr/>
           </a:p>
@@ -15498,7 +15751,15 @@
             </a:pPr>
             <a:r>
               <a:rPr lang="en"/>
-              <a:t>In ML, one would want to separate A from its proxies</a:t>
+              <a:t>In ML, one would want to separate </a:t>
+            </a:r>
+            <a:r>
+              <a:rPr b="1" i="1" lang="en"/>
+              <a:t>A</a:t>
+            </a:r>
+            <a:r>
+              <a:rPr lang="en"/>
+              <a:t> from its proxies</a:t>
             </a:r>
             <a:endParaRPr/>
           </a:p>
@@ -15538,7 +15799,15 @@
             </a:pPr>
             <a:r>
               <a:rPr lang="en"/>
-              <a:t>We envision the proxy to be a clearly defined observable quantity, which is highly correlated with A, yet in our view shouldn’t affect prediction</a:t>
+              <a:t>We envision the proxy to be a clearly defined observable quantity, which is highly correlated with </a:t>
+            </a:r>
+            <a:r>
+              <a:rPr b="1" i="1" lang="en"/>
+              <a:t>A</a:t>
+            </a:r>
+            <a:r>
+              <a:rPr lang="en"/>
+              <a:t>, yet in our view shouldn’t affect prediction</a:t>
             </a:r>
             <a:endParaRPr/>
           </a:p>
@@ -15976,6 +16245,32 @@
           </a:ln>
         </p:spPr>
       </p:pic>
+      <p:cxnSp>
+        <p:nvCxnSpPr>
+          <p:cNvPr id="274" name="Google Shape;274;p41"/>
+          <p:cNvCxnSpPr/>
+          <p:nvPr/>
+        </p:nvCxnSpPr>
+        <p:spPr>
+          <a:xfrm>
+            <a:off x="4594375" y="3472150"/>
+            <a:ext cx="1474800" cy="0"/>
+          </a:xfrm>
+          <a:prstGeom prst="straightConnector1">
+            <a:avLst/>
+          </a:prstGeom>
+          <a:noFill/>
+          <a:ln cap="flat" cmpd="sng" w="9525">
+            <a:solidFill>
+              <a:srgbClr val="FF0000"/>
+            </a:solidFill>
+            <a:prstDash val="solid"/>
+            <a:round/>
+            <a:headEnd len="med" w="med" type="none"/>
+            <a:tailEnd len="med" w="med" type="none"/>
+          </a:ln>
+        </p:spPr>
+      </p:cxnSp>
     </p:spTree>
   </p:cSld>
   <p:clrMapOvr>
@@ -16082,7 +16377,7 @@
   <p:cSld>
     <p:spTree>
       <p:nvGrpSpPr>
-        <p:cNvPr id="277" name="Shape 277"/>
+        <p:cNvPr id="278" name="Shape 278"/>
         <p:cNvGrpSpPr/>
         <p:nvPr/>
       </p:nvGrpSpPr>
@@ -16096,7 +16391,7 @@
       </p:grpSpPr>
       <p:sp>
         <p:nvSpPr>
-          <p:cNvPr id="278" name="Google Shape;278;p42"/>
+          <p:cNvPr id="279" name="Google Shape;279;p42"/>
           <p:cNvSpPr txBox="1"/>
           <p:nvPr>
             <p:ph type="title"/>
@@ -16136,7 +16431,7 @@
       </p:sp>
       <p:pic>
         <p:nvPicPr>
-          <p:cNvPr id="279" name="Google Shape;279;p42"/>
+          <p:cNvPr id="280" name="Google Shape;280;p42"/>
           <p:cNvPicPr preferRelativeResize="0"/>
           <p:nvPr/>
         </p:nvPicPr>
@@ -16175,7 +16470,7 @@
   <p:cSld>
     <p:spTree>
       <p:nvGrpSpPr>
-        <p:cNvPr id="283" name="Shape 283"/>
+        <p:cNvPr id="284" name="Shape 284"/>
         <p:cNvGrpSpPr/>
         <p:nvPr/>
       </p:nvGrpSpPr>
@@ -16189,7 +16484,7 @@
       </p:grpSpPr>
       <p:sp>
         <p:nvSpPr>
-          <p:cNvPr id="284" name="Google Shape;284;p43"/>
+          <p:cNvPr id="285" name="Google Shape;285;p43"/>
           <p:cNvSpPr txBox="1"/>
           <p:nvPr>
             <p:ph type="title"/>
@@ -16229,7 +16524,7 @@
       </p:sp>
       <p:pic>
         <p:nvPicPr>
-          <p:cNvPr id="285" name="Google Shape;285;p43"/>
+          <p:cNvPr id="286" name="Google Shape;286;p43"/>
           <p:cNvPicPr preferRelativeResize="0"/>
           <p:nvPr/>
         </p:nvPicPr>
@@ -16255,6 +16550,58 @@
           </a:ln>
         </p:spPr>
       </p:pic>
+      <p:cxnSp>
+        <p:nvCxnSpPr>
+          <p:cNvPr id="287" name="Google Shape;287;p43"/>
+          <p:cNvCxnSpPr/>
+          <p:nvPr/>
+        </p:nvCxnSpPr>
+        <p:spPr>
+          <a:xfrm flipH="1" rot="10800000">
+            <a:off x="5577525" y="3903750"/>
+            <a:ext cx="671400" cy="12000"/>
+          </a:xfrm>
+          <a:prstGeom prst="straightConnector1">
+            <a:avLst/>
+          </a:prstGeom>
+          <a:noFill/>
+          <a:ln cap="flat" cmpd="sng" w="9525">
+            <a:solidFill>
+              <a:srgbClr val="FF0000"/>
+            </a:solidFill>
+            <a:prstDash val="solid"/>
+            <a:round/>
+            <a:headEnd len="med" w="med" type="none"/>
+            <a:tailEnd len="med" w="med" type="none"/>
+          </a:ln>
+        </p:spPr>
+      </p:cxnSp>
+      <p:cxnSp>
+        <p:nvCxnSpPr>
+          <p:cNvPr id="288" name="Google Shape;288;p43"/>
+          <p:cNvCxnSpPr/>
+          <p:nvPr/>
+        </p:nvCxnSpPr>
+        <p:spPr>
+          <a:xfrm>
+            <a:off x="2987775" y="4107600"/>
+            <a:ext cx="707400" cy="0"/>
+          </a:xfrm>
+          <a:prstGeom prst="straightConnector1">
+            <a:avLst/>
+          </a:prstGeom>
+          <a:noFill/>
+          <a:ln cap="flat" cmpd="sng" w="9525">
+            <a:solidFill>
+              <a:srgbClr val="CC0000"/>
+            </a:solidFill>
+            <a:prstDash val="solid"/>
+            <a:round/>
+            <a:headEnd len="med" w="med" type="none"/>
+            <a:tailEnd len="med" w="med" type="none"/>
+          </a:ln>
+        </p:spPr>
+      </p:cxnSp>
     </p:spTree>
   </p:cSld>
   <p:clrMapOvr>
@@ -16268,7 +16615,7 @@
   <p:cSld>
     <p:spTree>
       <p:nvGrpSpPr>
-        <p:cNvPr id="289" name="Shape 289"/>
+        <p:cNvPr id="292" name="Shape 292"/>
         <p:cNvGrpSpPr/>
         <p:nvPr/>
       </p:nvGrpSpPr>
@@ -16282,7 +16629,7 @@
       </p:grpSpPr>
       <p:sp>
         <p:nvSpPr>
-          <p:cNvPr id="290" name="Google Shape;290;p44"/>
+          <p:cNvPr id="293" name="Google Shape;293;p44"/>
           <p:cNvSpPr txBox="1"/>
           <p:nvPr>
             <p:ph type="title"/>
@@ -16322,7 +16669,7 @@
       </p:sp>
       <p:pic>
         <p:nvPicPr>
-          <p:cNvPr id="291" name="Google Shape;291;p44"/>
+          <p:cNvPr id="294" name="Google Shape;294;p44"/>
           <p:cNvPicPr preferRelativeResize="0"/>
           <p:nvPr/>
         </p:nvPicPr>
@@ -16361,7 +16708,7 @@
   <p:cSld>
     <p:spTree>
       <p:nvGrpSpPr>
-        <p:cNvPr id="295" name="Shape 295"/>
+        <p:cNvPr id="298" name="Shape 298"/>
         <p:cNvGrpSpPr/>
         <p:nvPr/>
       </p:nvGrpSpPr>
@@ -16375,7 +16722,7 @@
       </p:grpSpPr>
       <p:sp>
         <p:nvSpPr>
-          <p:cNvPr id="296" name="Google Shape;296;p45"/>
+          <p:cNvPr id="299" name="Google Shape;299;p45"/>
           <p:cNvSpPr txBox="1"/>
           <p:nvPr>
             <p:ph type="title"/>
@@ -16415,7 +16762,7 @@
       </p:sp>
       <p:sp>
         <p:nvSpPr>
-          <p:cNvPr id="297" name="Google Shape;297;p45"/>
+          <p:cNvPr id="300" name="Google Shape;300;p45"/>
           <p:cNvSpPr txBox="1"/>
           <p:nvPr>
             <p:ph idx="1" type="body"/>
@@ -16455,7 +16802,7 @@
               <a:t>Key concepts of their conceptual framework are </a:t>
             </a:r>
             <a:r>
-              <a:rPr i="1" lang="en" sz="1400">
+              <a:rPr i="1" lang="en" sz="1400" u="sng">
                 <a:solidFill>
                   <a:srgbClr val="000000"/>
                 </a:solidFill>
@@ -16471,14 +16818,14 @@
               <a:t>and </a:t>
             </a:r>
             <a:r>
-              <a:rPr i="1" lang="en" sz="1400">
+              <a:rPr i="1" lang="en" sz="1400" u="sng">
                 <a:solidFill>
                   <a:srgbClr val="000000"/>
                 </a:solidFill>
               </a:rPr>
               <a:t>proxy variables</a:t>
             </a:r>
-            <a:endParaRPr i="1" sz="1400">
+            <a:endParaRPr i="1" sz="1400" u="sng">
               <a:solidFill>
                 <a:srgbClr val="000000"/>
               </a:solidFill>
@@ -16501,7 +16848,39 @@
                   <a:srgbClr val="000000"/>
                 </a:solidFill>
               </a:rPr>
-              <a:t>Develop a practical procedure to remove proxy discrimination given the structural equation model and analyze a similar approach for unresolved discrimination.</a:t>
+              <a:t>Develop a practical procedure to remove </a:t>
+            </a:r>
+            <a:r>
+              <a:rPr lang="en" sz="1400" u="sng">
+                <a:solidFill>
+                  <a:srgbClr val="000000"/>
+                </a:solidFill>
+              </a:rPr>
+              <a:t>proxy discrimination</a:t>
+            </a:r>
+            <a:r>
+              <a:rPr lang="en" sz="1400">
+                <a:solidFill>
+                  <a:srgbClr val="000000"/>
+                </a:solidFill>
+              </a:rPr>
+              <a:t> given the structural equation model and analyze a similar approach for </a:t>
+            </a:r>
+            <a:r>
+              <a:rPr lang="en" sz="1400" u="sng">
+                <a:solidFill>
+                  <a:srgbClr val="000000"/>
+                </a:solidFill>
+              </a:rPr>
+              <a:t>unresolved discrimination</a:t>
+            </a:r>
+            <a:r>
+              <a:rPr lang="en" sz="1400">
+                <a:solidFill>
+                  <a:srgbClr val="000000"/>
+                </a:solidFill>
+              </a:rPr>
+              <a:t>.</a:t>
             </a:r>
             <a:endParaRPr sz="1400">
               <a:solidFill>
@@ -16552,6 +16931,71 @@
                 </a:solidFill>
               </a:rPr>
               <a:t>The causal perspective suggests a number of interesting new directions at the technical, empirical, and conceptual level</a:t>
+            </a:r>
+            <a:endParaRPr/>
+          </a:p>
+        </p:txBody>
+      </p:sp>
+    </p:spTree>
+  </p:cSld>
+  <p:clrMapOvr>
+    <a:masterClrMapping/>
+  </p:clrMapOvr>
+</p:sld>
+</file>
+
+<file path=ppt/slides/slide34.xml><?xml version="1.0" encoding="utf-8"?>
+<p:sld xmlns:a="http://schemas.openxmlformats.org/drawingml/2006/main" xmlns:r="http://schemas.openxmlformats.org/officeDocument/2006/relationships" xmlns:mc="http://schemas.openxmlformats.org/markup-compatibility/2006" xmlns:mv="urn:schemas-microsoft-com:mac:vml" xmlns:p="http://schemas.openxmlformats.org/presentationml/2006/main" xmlns:c="http://schemas.openxmlformats.org/drawingml/2006/chart" xmlns:dgm="http://schemas.openxmlformats.org/drawingml/2006/diagram" xmlns:o="urn:schemas-microsoft-com:office:office" xmlns:v="urn:schemas-microsoft-com:vml" xmlns:pvml="urn:schemas-microsoft-com:office:powerpoint" xmlns:com="http://schemas.openxmlformats.org/drawingml/2006/compatibility" xmlns:p14="http://schemas.microsoft.com/office/powerpoint/2010/main" xmlns:p15="http://schemas.microsoft.com/office/powerpoint/2012/main">
+  <p:cSld>
+    <p:spTree>
+      <p:nvGrpSpPr>
+        <p:cNvPr id="304" name="Shape 304"/>
+        <p:cNvGrpSpPr/>
+        <p:nvPr/>
+      </p:nvGrpSpPr>
+      <p:grpSpPr>
+        <a:xfrm>
+          <a:off x="0" y="0"/>
+          <a:ext cx="0" cy="0"/>
+          <a:chOff x="0" y="0"/>
+          <a:chExt cx="0" cy="0"/>
+        </a:xfrm>
+      </p:grpSpPr>
+      <p:sp>
+        <p:nvSpPr>
+          <p:cNvPr id="305" name="Google Shape;305;p46"/>
+          <p:cNvSpPr txBox="1"/>
+          <p:nvPr>
+            <p:ph type="title"/>
+          </p:nvPr>
+        </p:nvSpPr>
+        <p:spPr>
+          <a:xfrm>
+            <a:off x="3562800" y="2451850"/>
+            <a:ext cx="2018400" cy="535200"/>
+          </a:xfrm>
+          <a:prstGeom prst="rect">
+            <a:avLst/>
+          </a:prstGeom>
+        </p:spPr>
+        <p:txBody>
+          <a:bodyPr anchorCtr="0" anchor="t" bIns="91425" lIns="91425" spcFirstLastPara="1" rIns="91425" wrap="square" tIns="91425">
+            <a:noAutofit/>
+          </a:bodyPr>
+          <a:lstStyle/>
+          <a:p>
+            <a:pPr indent="0" lvl="0" marL="0" rtl="0" algn="l">
+              <a:spcBef>
+                <a:spcPts val="0"/>
+              </a:spcBef>
+              <a:spcAft>
+                <a:spcPts val="0"/>
+              </a:spcAft>
+              <a:buNone/>
+            </a:pPr>
+            <a:r>
+              <a:rPr lang="en"/>
+              <a:t>Thank You!</a:t>
             </a:r>
             <a:endParaRPr/>
           </a:p>
@@ -16777,8 +17221,12 @@
               <a:buChar char="●"/>
             </a:pPr>
             <a:r>
+              <a:rPr lang="en" sz="1400" u="sng"/>
+              <a:t>Discrimination </a:t>
+            </a:r>
+            <a:r>
               <a:rPr lang="en" sz="1400"/>
-              <a:t>Discrimination refers to unfavourable treatment of people due to the membership to certain demographic groups</a:t>
+              <a:t>refers to unfavourable treatment of people due to the membership to certain demographic groups</a:t>
             </a:r>
             <a:endParaRPr sz="1400"/>
           </a:p>
@@ -16976,14 +17424,14 @@
               <a:buChar char="●"/>
             </a:pPr>
             <a:r>
-              <a:rPr lang="en" sz="1400"/>
+              <a:rPr lang="en" sz="1400" u="sng"/>
               <a:t>Can’t consider the ML algorithms be </a:t>
             </a:r>
             <a:r>
-              <a:rPr lang="en" sz="1400"/>
+              <a:rPr lang="en" sz="1400" u="sng"/>
               <a:t>mystical</a:t>
             </a:r>
-            <a:endParaRPr sz="1400"/>
+            <a:endParaRPr sz="1400" u="sng"/>
           </a:p>
           <a:p>
             <a:pPr indent="-317500" lvl="0" marL="457200" rtl="0" algn="l">

</xml_diff>